<commit_message>
Agrega presentación del estudio de mercado (ES/EN)
- Estudio_Mercado_CLT_Mexico_Latam_ES/EN (.pptx y .pdf), 37 diapositivas con transiciones: alcance, CLT, mercado mexicano, prospectos por zona, 80/20, competencia y FODA, comercio exterior, Latinoamérica y conclusiones
- Base visual compartida en src/ppt-base.js, usada por ambas presentaciones
- Crédito de fotos del stand más corto para que no se encime

Co-Authored-By: Claude Opus 5.5 <noreply@anthropic.com>
Claude-Session: https://claude.ai/code/session_012axCVDM5kAgj1VFnxhpsuM
</commit_message>
<xml_diff>
--- a/propuesta-clt/CLT_Proposal_Presentation_EN.pptx
+++ b/propuesta-clt/CLT_Proposal_Presentation_EN.pptx
@@ -140,13 +140,13 @@
   <p:extLst>
     <p:ext uri="{521415D9-36F7-43E2-AB2F-B90AF26B5E84}">
       <p14:sectionLst xmlns:p14="http://schemas.microsoft.com/office/powerpoint/2010/main">
-        <p14:section name="Opening" id="{42826b6a-84fc-bf56-e0ce-38b57c5184c0}">
+        <p14:section name="Opening" id="{391e0414-7884-2464-1d61-c060abd3fb3b}">
           <p14:sldIdLst>
             <p14:sldId id="256"/>
             <p14:sldId id="257"/>
           </p14:sldIdLst>
         </p14:section>
-        <p14:section name="The manufacturer" id="{fbc6f1a4-b551-2614-458b-c3722c3752ad}">
+        <p14:section name="The manufacturer" id="{dfdfd700-4457-a25f-b1e9-bf136265bee0}">
           <p14:sldIdLst>
             <p14:sldId id="258"/>
             <p14:sldId id="259"/>
@@ -157,7 +157,7 @@
             <p14:sldId id="264"/>
           </p14:sldIdLst>
         </p14:section>
-        <p14:section name="The Mexican market" id="{068d48d4-4d83-733c-ebe3-b5e73474db3d}">
+        <p14:section name="The Mexican market" id="{1111fb1f-1606-df73-1d10-c7cf88aac23e}">
           <p14:sldIdLst>
             <p14:sldId id="265"/>
             <p14:sldId id="266"/>
@@ -172,7 +172,7 @@
             <p14:sldId id="275"/>
           </p14:sldIdLst>
         </p14:section>
-        <p14:section name="Why TID · VSP · CEB" id="{cf684f60-a510-88db-f1d7-1f4852658d7a}">
+        <p14:section name="Why TID · VSP · CEB" id="{f7d2411e-01c6-1199-ff1d-3eab397b479d}">
           <p14:sldIdLst>
             <p14:sldId id="276"/>
             <p14:sldId id="277"/>
@@ -180,7 +180,7 @@
             <p14:sldId id="279"/>
           </p14:sldIdLst>
         </p14:section>
-        <p14:section name="Plan and investment" id="{eacd4fdf-e02a-e23e-6351-dedbf2a27f22}">
+        <p14:section name="Plan and investment" id="{7c4128b7-8f79-73e0-521f-4895f313d3b0}">
           <p14:sldIdLst>
             <p14:sldId id="280"/>
             <p14:sldId id="281"/>
@@ -189,7 +189,7 @@
             <p14:sldId id="284"/>
           </p14:sldIdLst>
         </p14:section>
-        <p14:section name="The proposal" id="{e373942f-88bd-e4b0-dbf0-48f001c99a5b}">
+        <p14:section name="The proposal" id="{9ccfddd4-df3d-2f1c-70f2-0e1f82c5cc0c}">
           <p14:sldIdLst>
             <p14:sldId id="285"/>
             <p14:sldId id="286"/>
@@ -30287,7 +30287,7 @@
                   <a:schemeClr val="accent2"/>
                 </a:solidFill>
               </a:rPr>
-              <a:t>Photos: VSP Printing</a:t>
+              <a:t>Photos: VSP</a:t>
             </a:r>
             <a:endParaRPr lang="en-US" sz="3000" dirty="0"/>
           </a:p>
@@ -30323,7 +30323,7 @@
                   <a:schemeClr val="tx2"/>
                 </a:solidFill>
               </a:rPr>
-              <a:t>VSP meeting with CLT</a:t>
+              <a:t>VSP Printing meeting with CLT</a:t>
             </a:r>
             <a:endParaRPr lang="en-US" sz="1200" dirty="0"/>
           </a:p>

</xml_diff>